<commit_message>
Gauntlet R1 build: L5 Robots Do the Boring Work — sort-board cover art, three tall sort boxes, listener strip for SL.6.4, exit adds who loses, studio jargon plain, jobs claims hedged, through-line sentence, listing per D2
Co-Authored-By: Claude Fable 5.1 <noreply@anthropic.com>
Claude-Session: https://claude.ai/code/session_01VWaJFc84eoA3U4f2VjTKjw
</commit_message>
<xml_diff>
--- a/products/ai-boring-work/dist/Robots Do the Boring Work - Slides.pptx
+++ b/products/ai-boring-work/dist/Robots Do the Boring Work - Slides.pptx
@@ -513,7 +513,7 @@
           <a:p>
             <a:r>
               <a:rPr lang="en-US" dirty="0"/>
-              <a:t>Open on this slide while students settle. Worksheet: The Studio Task Board, one per student. Fully unplugged — no devices at any point.</a:t>
+              <a:t>Open on this slide while students settle. Worksheet: The Studio Task Board, 2 pages, one per student — hand it out at the Main Activity, not before. Fully unplugged — no devices at any point; this deck is optional.</a:t>
             </a:r>
             <a:endParaRPr lang="en-US" dirty="0"/>
           </a:p>
@@ -601,7 +601,7 @@
           <a:p>
             <a:r>
               <a:rPr lang="en-US" dirty="0"/>
-              <a:t>Teach the delivery first (1 min): "Three moves: eyes up off the page, voice to the back wall, slow down on your claim." Pairs of pairs (4 min): two pairs face each other; each defends ONE choice in 30 seconds with the claim frame; the listening pair gives one keep and one fix. Circulate with the Defense Rubric (Teacher Guide p.2). Whole class (3 min): four or five pairs bring their most-argued call to the room. Gallery-walk variant: post the boards and tour for 2 minutes instead.</a:t>
+              <a:t>Transition in: "Stop there. Now you have to say it out loud — to people who might disagree." Teach the delivery first (1 min): "Three moves: eyes up off the page, voice to the back wall, slow down on your claim." Pairs of pairs (4 min): two pairs face each other; each pair defends ONE choice in 30 seconds with the claim frame; the listening pair scores the strip on the Speaker's sheet (eyes / voice / pace + one keep, one fix), then they switch. Every student is scored by a peer; you sample 3–4 pairs with the Defense Rubric (Teacher Guide p.3). What if a Speaker reads to the desk? Don't score — coach: "Eyes on us, one more time." Second try counts. Whole class (3 min): three pairs bring their most-argued choice to the room. Gallery-walk variant: post the boards and tour for 2 minutes instead. Transition out: "Swap sheets back — you need your own. Bottom of page 2: a job you actually know."</a:t>
             </a:r>
             <a:endParaRPr lang="en-US" dirty="0"/>
           </a:p>
@@ -689,7 +689,7 @@
           <a:p>
             <a:r>
               <a:rPr lang="en-US" dirty="0"/>
-              <a:t>Bottom of worksheet p.2. One line per column, plus a why for the human one. Collect; the Teacher Guide has an exemplar (an uncle's food truck) and the standards each line assesses.</a:t>
+              <a:t>Bottom of worksheet p.2, solo. What if a student says "I don't know anyone with a job"? "Your teacher has one. Sort mine." Exemplar (Teacher Guide p.2): the job — an uncle's food truck. Automate: posting the truck's daily location, and who loses something — the uncle, a little: the regulars who used to text "where you at?" now just check the post. Augment: planning how much food to buy — AI predicts, he decides. Keep human: joking with the regulars at the window, because that's why they come back. Proficient = a real task in every column + a real loss on the AUTOMATE line + a why on KEEP HUMAN. Collect.</a:t>
             </a:r>
             <a:endParaRPr lang="en-US" dirty="0"/>
           </a:p>
@@ -777,7 +777,7 @@
           <a:p>
             <a:r>
               <a:rPr lang="en-US" dirty="0"/>
-              <a:t>Close on this. Next in the unit: Lead Your AI Squad — Lesson 6, where students run a team of AI helpers on a real project.</a:t>
+              <a:t>Close on this. Next in the unit: Lead Your AI Squad (Lesson 6, sold separately) — students run a team of AI helpers on a real project.</a:t>
             </a:r>
             <a:endParaRPr lang="en-US" dirty="0"/>
           </a:p>
@@ -865,7 +865,7 @@
           <a:p>
             <a:r>
               <a:rPr lang="en-US" dirty="0"/>
-              <a:t>Take 4–5 answers and write them on the board. Pick two or three and ask the follow-up on the slide. Sort them as a class: repeats → robot bait, people stuff → hold on to it. A toll booth job repeats — but the toll collector also waves at every regular. Let students argue; the arguing is the point.</a:t>
+              <a:t>Take 4–5 answers and write them on the board. Pick two or three and ask the follow-up on the slide. Sort them as a class: repeats → give it to a robot; people stuff → keep it human. A cafeteria cashier's job repeats — but the cashier also knows which kid forgot lunch money. Let students argue; the arguing is the point. If nobody offers a job with people stuff in it, offer one: "School bus driver — repeats the route, but also notices who's crying in row six."</a:t>
             </a:r>
             <a:endParaRPr lang="en-US" dirty="0"/>
           </a:p>
@@ -953,7 +953,7 @@
           <a:p>
             <a:r>
               <a:rPr lang="en-US" dirty="0"/>
-              <a:t>Bridge, verbatim: "Here's the honest version, no robot apocalypse: nobody knows exactly which jobs change. What we can see already: The boring, repeating parts get automated; the human parts become the job. But every time a business automates something, somebody wins, somebody loses, and something could go wrong. Today YOU make those calls — for a recording studio."</a:t>
+              <a:t>Let pairs talk for 30 seconds, take two answers, then give the bridge verbatim: "Here's the honest version, no robot apocalypse: nobody can promise which jobs change, or how many. What we can see so far: the boring, repeating parts are the ones getting automated, and the human parts become more of the job. AI takes over tasks, not whole jobs — nobody can promise the final count. But every time a business automates something, somebody wins, somebody loses something, and something could go wrong. Today YOU make those decisions — for a recording studio." Transition: "So how do you decide what a robot should take? Three columns. Eyes on the board."</a:t>
             </a:r>
             <a:endParaRPr lang="en-US" dirty="0"/>
           </a:p>
@@ -1041,7 +1041,7 @@
           <a:p>
             <a:r>
               <a:rPr lang="en-US" dirty="0"/>
-              <a:t>Draw the three columns on the board as you define them — students will sort into the same three on the worksheet. Then advance to model the tradeoff lens on one studio task. With students, call it "the trade."</a:t>
+              <a:t>Draw the three columns on the board as you define them — students will sort into the same three on the worksheet. Gloss "the call" out loud: a call is a decision. Then advance to model the tradeoff lens on one studio task. With students, call it "the trade." What if a student says "automate everything, it's all boring"? Take it seriously: "Automate E — the nervous singer gets coached by a chatbot. Who lost something?" The trade does the arguing for you.</a:t>
             </a:r>
             <a:endParaRPr lang="en-US" dirty="0"/>
           </a:p>
@@ -1129,7 +1129,7 @@
           <a:p>
             <a:r>
               <a:rPr lang="en-US" dirty="0"/>
-              <a:t>Walk the three questions out loud, one at a time, before revealing the answers if you can. Jaylen runs the front desk at Big Dream Studio; students meet him on the worksheet. The point: the same person can win AND lose from one call.</a:t>
+              <a:t>Ask the three questions out loud, one at a time, and take a guess from the room before you read each answer on the right. Jaylen runs the front desk at Big Dream Studio; students meet him on the worksheet. The point: the same person can win AND lose from one decision. Key for the trade you are modeling — Who wins: Jaylen (hours back). Who loses something: Jaylen (the texts were how he learned every artist's name). What could go wrong: a cheerful reminder after a canceled session.</a:t>
             </a:r>
             <a:endParaRPr lang="en-US" dirty="0"/>
           </a:p>
@@ -1217,7 +1217,7 @@
           <a:p>
             <a:r>
               <a:rPr lang="en-US" dirty="0"/>
-              <a:t>Say it plainly: "The column is the easy part. The trade is the real thinking. In this room, 'because robots' is not a reason. 'Who wins, who loses, what could go wrong' — that's a reason." The worksheet repeats the line on p.2.</a:t>
+              <a:t>Say it plainly: "The column is the easy part. The trade is the real thinking. In this room, 'because robots' is not a reason. 'Who wins, who loses something, what could go wrong' — that's a reason." The worksheet repeats the line on p.2. Hand-out line: "Worksheets coming around — one each, pairs of two. Page 1: meet Nia, Ravi and Jaylen, then read tasks A to L. Don't sort yet."</a:t>
             </a:r>
             <a:endParaRPr lang="en-US" dirty="0"/>
           </a:p>
@@ -1305,7 +1305,7 @@
           <a:p>
             <a:r>
               <a:rPr lang="en-US" dirty="0"/>
-              <a:t>Hand out worksheets if you haven't. Nia owns the studio and coaches the artists, Ravi runs the mixing boards, Jaylen runs the front desk. Leave the next two slides (the task list) up during the Sort. Support: sort 8 tasks instead of 12 — skip B, F, J, L.</a:t>
+              <a:t>Nia owns the studio and coaches the artists, Ravi runs the mixing boards, Jaylen runs the front desk. Leave the next two slides (the task list) up during the Sort. Sort what-if: a pair is stuck → "Does it repeat, or is it people stuff?"; a pair puts ten letters in AUTOMATE → "Which two would you hate to lose a person on?" Transition into trade cards: "Pens down. Page 2. Pick the TWO choices you argued about most — those are your trade cards." Trade-card what-if: "nobody loses" → "Even Jaylen lost something. Who used to do this task? What did they get from it?" Support: sort 8 tasks instead of 12 — skip B, F, J, L (every column still gets two).</a:t>
             </a:r>
             <a:endParaRPr lang="en-US" dirty="0"/>
           </a:p>
@@ -1393,7 +1393,7 @@
           <a:p>
             <a:r>
               <a:rPr lang="en-US" dirty="0"/>
-              <a:t>Same twelve tasks as the worksheet. Circulate during the Sort; when a pair is stuck, ask "Does it repeat, or is it people stuff?" Most tasks are defensibly AUGMENT — the column matters far less than the defense.</a:t>
+              <a:t>Same twelve tasks as the worksheet. Likely-column key (grade the trade, not the column — most tasks are defensibly AUGMENT): A Automate — a chirpy text after a cancellation stings. B Automate — nobody misses it; the risk is silent failure, so spot-check. C Augment — AI drafts fast, but the studio's voice is Jaylen's. D Augment — AI gets most of the way; Ravi's ears decide. E Keep human — confidence is the whole point; a chatbot coach costs the singer. F Automate — a job nobody wants; a loyal regular gets a cold nudge. Circulate; when a pair is stuck, ask "Does it repeat, or is it people stuff?"</a:t>
             </a:r>
             <a:endParaRPr lang="en-US" dirty="0"/>
           </a:p>
@@ -1481,7 +1481,7 @@
           <a:p>
             <a:r>
               <a:rPr lang="en-US" dirty="0"/>
-              <a:t>Flip between this slide and the last one during the Sort. If the class splits three ways on one task, nobody's right — say so, and save it for the share-out: "Convince me. Who wins? Who loses? What breaks?"</a:t>
+              <a:t>Likely-column key: G Keep human / Augment — taste is Nia's edge; AI can report what's trending, it doesn't decide. H Keep human / Augment — craft plus judgment; AI can suggest, hands do the work. I Keep human — trust and reading the room; a bot can cost the studio the booking. J Automate — pure transcription; it can mishear a line, so the artist checks. K Automate — same answers daily; the risk is the sixth question. L Keep human / Augment — the mood is live connection; AI can draft the checklist. Flip between this slide and the last one during the Sort. If the class splits three ways on one task, nobody's right — say so, and save it for the share-out: "Convince me. Who wins? Who loses something? What breaks?"</a:t>
             </a:r>
             <a:endParaRPr lang="en-US" dirty="0"/>
           </a:p>
@@ -2067,7 +2067,7 @@
                 <a:ea typeface="Arial" pitchFamily="34" charset="-122"/>
                 <a:cs typeface="Arial" pitchFamily="34" charset="-120"/>
               </a:rPr>
-              <a:t>Your class runs Big Dream Studio, a recording studio with too much to do. You decide what the AI does, what it helps with, and what it never touches — and you own the trade behind every call.</a:t>
+              <a:t>Your class runs Big Dream Studio, a recording studio with too much to do. You decide what the AI does, what it helps with, and what it never touches — and you own the trade behind every choice.</a:t>
             </a:r>
             <a:endParaRPr lang="en-US" sz="1300" dirty="0"/>
           </a:p>
@@ -2214,7 +2214,7 @@
         <p:spPr>
           <a:xfrm>
             <a:off x="3204972" y="3977640"/>
-            <a:ext cx="1485900" cy="310896"/>
+            <a:ext cx="2418588" cy="310896"/>
           </a:xfrm>
           <a:prstGeom prst="roundRect">
             <a:avLst>
@@ -2241,7 +2241,7 @@
         <p:spPr>
           <a:xfrm>
             <a:off x="3204972" y="3977640"/>
-            <a:ext cx="1485900" cy="310896"/>
+            <a:ext cx="2418588" cy="310896"/>
           </a:xfrm>
           <a:prstGeom prst="rect">
             <a:avLst/>
@@ -2265,7 +2265,7 @@
                 <a:ea typeface="Arial" pitchFamily="34" charset="-122"/>
                 <a:cs typeface="Arial" pitchFamily="34" charset="-120"/>
               </a:rPr>
-              <a:t>Works unplugged</a:t>
+              <a:t>No prep · No devices needed</a:t>
             </a:r>
             <a:endParaRPr lang="en-US" sz="1000" dirty="0"/>
           </a:p>
@@ -2523,7 +2523,7 @@
                 <a:ea typeface="Arial" pitchFamily="34" charset="-122"/>
                 <a:cs typeface="Arial" pitchFamily="34" charset="-120"/>
               </a:rPr>
-              <a:t>1.  Eyes up off the page.</a:t>
+              <a:t>Two pairs face each other. Speakers: defend ONE choice in 30 seconds. Then switch.</a:t>
             </a:r>
             <a:endParaRPr lang="en-US" sz="1800" dirty="0"/>
           </a:p>
@@ -2544,7 +2544,7 @@
                 <a:ea typeface="Arial" pitchFamily="34" charset="-122"/>
                 <a:cs typeface="Arial" pitchFamily="34" charset="-120"/>
               </a:rPr>
-              <a:t>2.  Voice to the back wall.</a:t>
+              <a:t>1.  Eyes up off the page.</a:t>
             </a:r>
             <a:endParaRPr lang="en-US" sz="1800" dirty="0"/>
           </a:p>
@@ -2565,7 +2565,7 @@
                 <a:ea typeface="Arial" pitchFamily="34" charset="-122"/>
                 <a:cs typeface="Arial" pitchFamily="34" charset="-120"/>
               </a:rPr>
-              <a:t>3.  Slow down on your claim.</a:t>
+              <a:t>2.  Voice to the back wall.</a:t>
             </a:r>
             <a:endParaRPr lang="en-US" sz="1800" dirty="0"/>
           </a:p>
@@ -2586,7 +2586,7 @@
                 <a:ea typeface="Arial" pitchFamily="34" charset="-122"/>
                 <a:cs typeface="Arial" pitchFamily="34" charset="-120"/>
               </a:rPr>
-              <a:t>Claim frame:  "Task ___ belongs in ___ because ___ — and the trade is ___."</a:t>
+              <a:t>3.  Slow down on your claim.</a:t>
             </a:r>
             <a:endParaRPr lang="en-US" sz="1800" dirty="0"/>
           </a:p>
@@ -2607,7 +2607,28 @@
                 <a:ea typeface="Arial" pitchFamily="34" charset="-122"/>
                 <a:cs typeface="Arial" pitchFamily="34" charset="-120"/>
               </a:rPr>
-              <a:t>30 seconds per pair. The listening pair answers with one keep and one fix.</a:t>
+              <a:t>Claim frame:  Task ___ belongs in ___ because ___ — and the trade is ___</a:t>
+            </a:r>
+            <a:endParaRPr lang="en-US" sz="1800" dirty="0"/>
+          </a:p>
+          <a:p>
+            <a:pPr marL="342900" indent="-342900">
+              <a:spcAft>
+                <a:spcPts val="800"/>
+              </a:spcAft>
+              <a:buSzPct val="100000"/>
+              <a:buChar char="■"/>
+            </a:pPr>
+            <a:r>
+              <a:rPr lang="en-US" sz="1800" dirty="0">
+                <a:solidFill>
+                  <a:srgbClr val="E8E8F5"/>
+                </a:solidFill>
+                <a:latin typeface="Arial" pitchFamily="34" charset="0"/>
+                <a:ea typeface="Arial" pitchFamily="34" charset="-122"/>
+                <a:cs typeface="Arial" pitchFamily="34" charset="-120"/>
+              </a:rPr>
+              <a:t>Listeners: tick eyes / voice / pace on the Speaker's sheet, then write one keep and one fix.</a:t>
             </a:r>
             <a:endParaRPr lang="en-US" sz="1800" dirty="0"/>
           </a:p>
@@ -2822,7 +2843,7 @@
                 <a:ea typeface="Arial" pitchFamily="34" charset="-122"/>
                 <a:cs typeface="Arial" pitchFamily="34" charset="-120"/>
               </a:rPr>
-              <a:t>Exit Ticket — Take It Home</a:t>
+              <a:t>Exit Ticket — A Real Job You Know</a:t>
             </a:r>
             <a:endParaRPr lang="en-US" sz="2600" dirty="0"/>
           </a:p>
@@ -2865,7 +2886,7 @@
                 <a:ea typeface="Arial" pitchFamily="34" charset="-122"/>
                 <a:cs typeface="Arial" pitchFamily="34" charset="-120"/>
               </a:rPr>
-              <a:t>The job: one somebody in your life actually has — family, neighbor, coach, teacher.</a:t>
+              <a:t>The job: one somebody in your life really has — family, neighbor, coach, teacher.</a:t>
             </a:r>
             <a:endParaRPr lang="en-US" sz="1800" dirty="0"/>
           </a:p>
@@ -2886,7 +2907,7 @@
                 <a:ea typeface="Arial" pitchFamily="34" charset="-122"/>
                 <a:cs typeface="Arial" pitchFamily="34" charset="-120"/>
               </a:rPr>
-              <a:t>AUTOMATE — one boring, repeating task AI should take.</a:t>
+              <a:t>AUTOMATE — one boring, repeating task AI should take — and who loses something when it does.</a:t>
             </a:r>
             <a:endParaRPr lang="en-US" sz="1800" dirty="0"/>
           </a:p>
@@ -3141,7 +3162,7 @@
                 <a:ea typeface="Arial" pitchFamily="34" charset="-122"/>
                 <a:cs typeface="Arial" pitchFamily="34" charset="-120"/>
               </a:rPr>
-              <a:t>The people who win with AI aren't the ones who fear it — they're the ones who decide what it does.</a:t>
+              <a:t>Every AI job runs human → AI → human: a person starts it, AI does the middle, a person checks and decides. The people who win with AI are the ones who decide what it does.</a:t>
             </a:r>
             <a:endParaRPr lang="en-US" sz="1600" dirty="0"/>
           </a:p>
@@ -3527,7 +3548,7 @@
                 <a:ea typeface="Arial" pitchFamily="34" charset="-122"/>
                 <a:cs typeface="Arial" pitchFamily="34" charset="-120"/>
               </a:rPr>
-              <a:t>Or is it "boring" but secretly full of people stuff — helping, noticing, talking someone down?</a:t>
+              <a:t>Or is it "boring" but secretly full of people stuff — helping, noticing, calming someone down?</a:t>
             </a:r>
             <a:endParaRPr lang="en-US" sz="1500" dirty="0"/>
           </a:p>
@@ -3593,7 +3614,7 @@
                 <a:ea typeface="Arial" pitchFamily="34" charset="-122"/>
                 <a:cs typeface="Arial" pitchFamily="34" charset="-120"/>
               </a:rPr>
-              <a:t>Repeats  →  robot bait.     People stuff  →  hold on to it.</a:t>
+              <a:t>Repeats  →  give it to a robot.     People stuff  →  keep it human.</a:t>
             </a:r>
             <a:endParaRPr lang="en-US" sz="1500" dirty="0"/>
           </a:p>
@@ -3820,7 +3841,7 @@
                 <a:ea typeface="Arial" pitchFamily="34" charset="-122"/>
                 <a:cs typeface="Arial" pitchFamily="34" charset="-120"/>
               </a:rPr>
-              <a:t>Nobody knows exactly which jobs change. So what CAN we see already?</a:t>
+              <a:t>Nobody can promise which jobs change. So what CAN we see already?</a:t>
             </a:r>
             <a:endParaRPr lang="en-US" sz="3000" dirty="0"/>
           </a:p>
@@ -3859,7 +3880,7 @@
                 <a:ea typeface="Arial" pitchFamily="34" charset="-122"/>
                 <a:cs typeface="Arial" pitchFamily="34" charset="-120"/>
               </a:rPr>
-              <a:t>The boring, repeating parts get automated. The human parts become the job. And every time a business automates something: somebody wins, somebody loses, something could go wrong.</a:t>
+              <a:t>Thirty seconds with a partner: look at the boring jobs on the board. Which parts repeat — and which parts are people stuff?</a:t>
             </a:r>
             <a:endParaRPr lang="en-US" sz="1600" dirty="0"/>
           </a:p>
@@ -4243,7 +4264,7 @@
                 <a:ea typeface="Arial" pitchFamily="34" charset="-122"/>
                 <a:cs typeface="Arial" pitchFamily="34" charset="-120"/>
               </a:rPr>
-              <a:t>Boring and repeating. No judgment calls. Hand it to AI.</a:t>
+              <a:t>Boring and repeating — no decisions to make. Hand it to AI.</a:t>
             </a:r>
             <a:endParaRPr lang="en-US" sz="1400" dirty="0"/>
           </a:p>
@@ -4412,7 +4433,7 @@
                 <a:ea typeface="Arial" pitchFamily="34" charset="-122"/>
                 <a:cs typeface="Arial" pitchFamily="34" charset="-120"/>
               </a:rPr>
-              <a:t>A human makes the call, AI helps out.</a:t>
+              <a:t>A human makes the call — the decision — and AI helps out.</a:t>
             </a:r>
             <a:endParaRPr lang="en-US" sz="1400" dirty="0"/>
           </a:p>
@@ -4581,7 +4602,7 @@
                 <a:ea typeface="Arial" pitchFamily="34" charset="-122"/>
                 <a:cs typeface="Arial" pitchFamily="34" charset="-120"/>
               </a:rPr>
-              <a:t>Coaching, taste, being there for someone. The human IS the product.</a:t>
+              <a:t>Coaching, taste, being there for someone. The person is the whole point.</a:t>
             </a:r>
             <a:endParaRPr lang="en-US" sz="1400" dirty="0"/>
           </a:p>
@@ -4722,7 +4743,7 @@
               <a:buNone/>
             </a:pPr>
             <a:r>
-              <a:rPr lang="en-US" sz="2200" b="1" dirty="0">
+              <a:rPr lang="en-US" sz="2500" b="1" dirty="0">
                 <a:solidFill>
                   <a:srgbClr val="FFB020"/>
                 </a:solidFill>
@@ -4730,9 +4751,9 @@
                 <a:ea typeface="Arial" pitchFamily="34" charset="-122"/>
                 <a:cs typeface="Arial" pitchFamily="34" charset="-120"/>
               </a:rPr>
-              <a:t>Model it live — the column, then the trade</a:t>
-            </a:r>
-            <a:endParaRPr lang="en-US" sz="2200" dirty="0"/>
+              <a:t>Watch one get sorted — then the trade</a:t>
+            </a:r>
+            <a:endParaRPr lang="en-US" sz="2500" dirty="0"/>
           </a:p>
         </p:txBody>
       </p:sp>
@@ -4978,7 +4999,7 @@
               <a:buNone/>
             </a:pPr>
             <a:r>
-              <a:rPr lang="en-US" sz="1400" dirty="0">
+              <a:rPr lang="en-US" sz="1700" dirty="0">
                 <a:solidFill>
                   <a:srgbClr val="FFFFFF"/>
                 </a:solidFill>
@@ -4986,22 +5007,22 @@
                 <a:ea typeface="Arial" pitchFamily="34" charset="-122"/>
                 <a:cs typeface="Arial" pitchFamily="34" charset="-120"/>
               </a:rPr>
-              <a:t>Who wins?  Jaylen — gets hours back for the artists in the building.</a:t>
-            </a:r>
-            <a:endParaRPr lang="en-US" sz="1400" dirty="0"/>
+              <a:t>Wins: Jaylen — hours back for the artists.</a:t>
+            </a:r>
+            <a:endParaRPr lang="en-US" sz="1700" dirty="0"/>
           </a:p>
           <a:p>
             <a:pPr indent="0" marL="0">
               <a:buNone/>
             </a:pPr>
-            <a:endParaRPr lang="en-US" sz="1400" dirty="0"/>
+            <a:endParaRPr lang="en-US" sz="1700" dirty="0"/>
           </a:p>
           <a:p>
             <a:pPr indent="0" marL="0">
               <a:buNone/>
             </a:pPr>
             <a:r>
-              <a:rPr lang="en-US" sz="1400" dirty="0">
+              <a:rPr lang="en-US" sz="1700" dirty="0">
                 <a:solidFill>
                   <a:srgbClr val="FFFFFF"/>
                 </a:solidFill>
@@ -5009,22 +5030,22 @@
                 <a:ea typeface="Arial" pitchFamily="34" charset="-122"/>
                 <a:cs typeface="Arial" pitchFamily="34" charset="-120"/>
               </a:rPr>
-              <a:t>Who loses something?  Jaylen, a little — sending those texts is how he learned every artist's name.</a:t>
-            </a:r>
-            <a:endParaRPr lang="en-US" sz="1400" dirty="0"/>
+              <a:t>Loses something: Jaylen — those texts taught him every name.</a:t>
+            </a:r>
+            <a:endParaRPr lang="en-US" sz="1700" dirty="0"/>
           </a:p>
           <a:p>
             <a:pPr indent="0" marL="0">
               <a:buNone/>
             </a:pPr>
-            <a:endParaRPr lang="en-US" sz="1400" dirty="0"/>
+            <a:endParaRPr lang="en-US" sz="1700" dirty="0"/>
           </a:p>
           <a:p>
             <a:pPr indent="0" marL="0">
               <a:buNone/>
             </a:pPr>
             <a:r>
-              <a:rPr lang="en-US" sz="1400" dirty="0">
+              <a:rPr lang="en-US" sz="1700" dirty="0">
                 <a:solidFill>
                   <a:srgbClr val="FFFFFF"/>
                 </a:solidFill>
@@ -5032,9 +5053,9 @@
                 <a:ea typeface="Arial" pitchFamily="34" charset="-122"/>
                 <a:cs typeface="Arial" pitchFamily="34" charset="-120"/>
               </a:rPr>
-              <a:t>What could go wrong?  A cheerful reminder lands after a canceled session.</a:t>
-            </a:r>
-            <a:endParaRPr lang="en-US" sz="1400" dirty="0"/>
+              <a:t>Could go wrong: a cheery text after a canceled session.</a:t>
+            </a:r>
+            <a:endParaRPr lang="en-US" sz="1700" dirty="0"/>
           </a:p>
         </p:txBody>
       </p:sp>
@@ -5259,7 +5280,7 @@
                 <a:ea typeface="Arial" pitchFamily="34" charset="-122"/>
                 <a:cs typeface="Arial" pitchFamily="34" charset="-120"/>
               </a:rPr>
-              <a:t>"Who wins, who loses, what could go wrong" — that's a reason. The column is the easy part. The trade is the real thinking.</a:t>
+              <a:t>"Who wins, who loses something, what could go wrong" — that's a reason. The column is the easy part. The trade is the real thinking.</a:t>
             </a:r>
             <a:endParaRPr lang="en-US" sz="1500" dirty="0"/>
           </a:p>
@@ -5616,7 +5637,7 @@
                 <a:ea typeface="Arial" pitchFamily="34" charset="-122"/>
                 <a:cs typeface="Arial" pitchFamily="34" charset="-120"/>
               </a:rPr>
-              <a:t>Pairs. Sort tasks A–L into the three columns. House rule: every column gets at least two tasks. Disagree? Talk it out — either can be right.</a:t>
+              <a:t>Pairs. Write each letter A–L in its column — as many as belong. Rule: every column gets at least two. Disagree? Talk it out.</a:t>
             </a:r>
             <a:endParaRPr lang="en-US" sz="1300" dirty="0"/>
           </a:p>
@@ -5758,7 +5779,7 @@
                 <a:ea typeface="Arial" pitchFamily="34" charset="-122"/>
                 <a:cs typeface="Arial" pitchFamily="34" charset="-120"/>
               </a:rPr>
-              <a:t>Pick TWO of your calls. On worksheet p.2, write the trade for each: who wins, who loses, what could go wrong.</a:t>
+              <a:t>Pick TWO of your choices. On page 2, write the trade for each: who wins, who loses something, what could go wrong.</a:t>
             </a:r>
             <a:endParaRPr lang="en-US" sz="1300" dirty="0"/>
           </a:p>
@@ -6013,7 +6034,7 @@
                 <a:ea typeface="Arial" pitchFamily="34" charset="-122"/>
                 <a:cs typeface="Arial" pitchFamily="34" charset="-120"/>
               </a:rPr>
-              <a:t>D —  Mix a rough first version of a new artist's demo  (Ravi)</a:t>
+              <a:t>D —  Mix a rough first version of a new artist's song  (Ravi)</a:t>
             </a:r>
             <a:endParaRPr lang="en-US" sz="1800" dirty="0"/>
           </a:p>
@@ -6034,7 +6055,7 @@
                 <a:ea typeface="Arial" pitchFamily="34" charset="-122"/>
                 <a:cs typeface="Arial" pitchFamily="34" charset="-120"/>
               </a:rPr>
-              <a:t>E —  Coach a nervous first-time artist through her first take  (Nia)</a:t>
+              <a:t>E —  Coach a nervous first-time singer through her first recording  (Nia)</a:t>
             </a:r>
             <a:endParaRPr lang="en-US" sz="1800" dirty="0"/>
           </a:p>
@@ -6239,7 +6260,7 @@
               <a:buChar char="■"/>
             </a:pPr>
             <a:r>
-              <a:rPr lang="en-US" sz="1800" dirty="0">
+              <a:rPr lang="en-US" sz="1700" dirty="0">
                 <a:solidFill>
                   <a:srgbClr val="E8E8F5"/>
                 </a:solidFill>
@@ -6247,9 +6268,9 @@
                 <a:ea typeface="Arial" pitchFamily="34" charset="-122"/>
                 <a:cs typeface="Arial" pitchFamily="34" charset="-120"/>
               </a:rPr>
-              <a:t>G —  Pick which of an artist's five new songs is the single  (Nia)</a:t>
-            </a:r>
-            <a:endParaRPr lang="en-US" sz="1800" dirty="0"/>
+              <a:t>G —  Pick which of an artist's five new songs to release first  (Nia)</a:t>
+            </a:r>
+            <a:endParaRPr lang="en-US" sz="1700" dirty="0"/>
           </a:p>
           <a:p>
             <a:pPr marL="342900" indent="-342900">
@@ -6260,7 +6281,7 @@
               <a:buChar char="■"/>
             </a:pPr>
             <a:r>
-              <a:rPr lang="en-US" sz="1800" dirty="0">
+              <a:rPr lang="en-US" sz="1700" dirty="0">
                 <a:solidFill>
                   <a:srgbClr val="E8E8F5"/>
                 </a:solidFill>
@@ -6268,9 +6289,9 @@
                 <a:ea typeface="Arial" pitchFamily="34" charset="-122"/>
                 <a:cs typeface="Arial" pitchFamily="34" charset="-120"/>
               </a:rPr>
-              <a:t>H —  Make the room sound less echoey and set the mics for a live band  (Ravi)</a:t>
-            </a:r>
-            <a:endParaRPr lang="en-US" sz="1800" dirty="0"/>
+              <a:t>H —  Set up the microphones for a live band and fix the echo  (Ravi)</a:t>
+            </a:r>
+            <a:endParaRPr lang="en-US" sz="1700" dirty="0"/>
           </a:p>
           <a:p>
             <a:pPr marL="342900" indent="-342900">
@@ -6281,7 +6302,7 @@
               <a:buChar char="■"/>
             </a:pPr>
             <a:r>
-              <a:rPr lang="en-US" sz="1800" dirty="0">
+              <a:rPr lang="en-US" sz="1700" dirty="0">
                 <a:solidFill>
                   <a:srgbClr val="E8E8F5"/>
                 </a:solidFill>
@@ -6291,7 +6312,7 @@
               </a:rPr>
               <a:t>I —  Agree on a price with a group that wants the studio for three days  (Nia)</a:t>
             </a:r>
-            <a:endParaRPr lang="en-US" sz="1800" dirty="0"/>
+            <a:endParaRPr lang="en-US" sz="1700" dirty="0"/>
           </a:p>
           <a:p>
             <a:pPr marL="342900" indent="-342900">
@@ -6302,7 +6323,7 @@
               <a:buChar char="■"/>
             </a:pPr>
             <a:r>
-              <a:rPr lang="en-US" sz="1800" dirty="0">
+              <a:rPr lang="en-US" sz="1700" dirty="0">
                 <a:solidFill>
                   <a:srgbClr val="E8E8F5"/>
                 </a:solidFill>
@@ -6310,9 +6331,9 @@
                 <a:ea typeface="Arial" pitchFamily="34" charset="-122"/>
                 <a:cs typeface="Arial" pitchFamily="34" charset="-120"/>
               </a:rPr>
-              <a:t>J —  Type up the lyrics from yesterday's freestyle session  (Ravi)</a:t>
-            </a:r>
-            <a:endParaRPr lang="en-US" sz="1800" dirty="0"/>
+              <a:t>J —  Type up the lyrics from yesterday's made-up-on-the-spot rap session  (Ravi)</a:t>
+            </a:r>
+            <a:endParaRPr lang="en-US" sz="1700" dirty="0"/>
           </a:p>
           <a:p>
             <a:pPr marL="342900" indent="-342900">
@@ -6323,7 +6344,7 @@
               <a:buChar char="■"/>
             </a:pPr>
             <a:r>
-              <a:rPr lang="en-US" sz="1800" dirty="0">
+              <a:rPr lang="en-US" sz="1700" dirty="0">
                 <a:solidFill>
                   <a:srgbClr val="E8E8F5"/>
                 </a:solidFill>
@@ -6333,7 +6354,7 @@
               </a:rPr>
               <a:t>K —  Answer the same five questions everyone emails (price, hours, parking)  (Jaylen)</a:t>
             </a:r>
-            <a:endParaRPr lang="en-US" sz="1800" dirty="0"/>
+            <a:endParaRPr lang="en-US" sz="1700" dirty="0"/>
           </a:p>
           <a:p>
             <a:pPr marL="342900" indent="-342900">
@@ -6344,7 +6365,7 @@
               <a:buChar char="■"/>
             </a:pPr>
             <a:r>
-              <a:rPr lang="en-US" sz="1800" dirty="0">
+              <a:rPr lang="en-US" sz="1700" dirty="0">
                 <a:solidFill>
                   <a:srgbClr val="E8E8F5"/>
                 </a:solidFill>
@@ -6352,9 +6373,9 @@
                 <a:ea typeface="Arial" pitchFamily="34" charset="-122"/>
                 <a:cs typeface="Arial" pitchFamily="34" charset="-120"/>
               </a:rPr>
-              <a:t>L —  Plan the set order and vibe for showcase night  (Nia)</a:t>
-            </a:r>
-            <a:endParaRPr lang="en-US" sz="1800" dirty="0"/>
+              <a:t>L —  Plan the song order and mood for the big show night  (Nia)</a:t>
+            </a:r>
+            <a:endParaRPr lang="en-US" sz="1700" dirty="0"/>
           </a:p>
         </p:txBody>
       </p:sp>

</xml_diff>

<commit_message>
Gauntlet R2 fixes: L4 one-object feed-card cover, print-fit plan restored, numbered peeves, check not tick, hedged hook; L5 hedged cover line, speaker/listener mapping, 24px blanks, full-width because line, jobs hedge on slide 12
Co-Authored-By: Claude Fable 5.1 <noreply@anthropic.com>
Claude-Session: https://claude.ai/code/session_01VWaJFc84eoA3U4f2VjTKjw
</commit_message>
<xml_diff>
--- a/products/ai-boring-work/dist/Robots Do the Boring Work - Slides.pptx
+++ b/products/ai-boring-work/dist/Robots Do the Boring Work - Slides.pptx
@@ -601,7 +601,7 @@
           <a:p>
             <a:r>
               <a:rPr lang="en-US" dirty="0"/>
-              <a:t>Transition in: "Stop there. Now you have to say it out loud — to people who might disagree." Teach the delivery first (1 min): "Three moves: eyes up off the page, voice to the back wall, slow down on your claim." Pairs of pairs (4 min): two pairs face each other; each pair defends ONE choice in 30 seconds with the claim frame; the listening pair scores the strip on the Speaker's sheet (eyes / voice / pace + one keep, one fix), then they switch. Every student is scored by a peer; you sample 3–4 pairs with the Defense Rubric (Teacher Guide p.3). What if a Speaker reads to the desk? Don't score — coach: "Eyes on us, one more time." Second try counts. Whole class (3 min): three pairs bring their most-argued choice to the room. Gallery-walk variant: post the boards and tour for 2 minutes instead. Transition out: "Swap sheets back — you need your own. Bottom of page 2: a job you actually know."</a:t>
+              <a:t>Transition in: "Stop there. Now you have to say it out loud — to people who might disagree." Teach the delivery first (1 min): "Three moves: eyes up off the page, voice to the back wall, slow down on your claim." Pairs of pairs (5 min): two pairs face each other. Each Speaker says the frame once — 30 seconds each. Listener 1 marks Speaker 1's sheet, Listener 2 marks Speaker 2's (eyes / voice / pace + one keep, one fix); then the pairs switch roles. Each student's claim is scored by a peer; you sample 3–4 pairs with the Defense Rubric (Teacher Guide p.3). What if a Speaker reads to the desk? Don't score — coach: "Eyes on us, one more time." Second try counts. Odd number of pairs → one trio of pairs rotates; sample that group. Whole class (2 min): three pairs bring their most-argued choice to the room. Gallery-walk variant: post the boards and tour for 2 minutes instead. Transition out: "Swap sheets back — you need your own. Bottom of page 2: a job you actually know."</a:t>
             </a:r>
             <a:endParaRPr lang="en-US" dirty="0"/>
           </a:p>
@@ -2133,7 +2133,7 @@
                 <a:ea typeface="Arial" pitchFamily="34" charset="-122"/>
                 <a:cs typeface="Arial" pitchFamily="34" charset="-120"/>
               </a:rPr>
-              <a:t>Grades 6-8</a:t>
+              <a:t>Grades 6–8</a:t>
             </a:r>
             <a:endParaRPr lang="en-US" sz="1000" dirty="0"/>
           </a:p>
@@ -2523,7 +2523,7 @@
                 <a:ea typeface="Arial" pitchFamily="34" charset="-122"/>
                 <a:cs typeface="Arial" pitchFamily="34" charset="-120"/>
               </a:rPr>
-              <a:t>Two pairs face each other. Speakers: defend ONE choice in 30 seconds. Then switch.</a:t>
+              <a:t>Two pairs face each other. Each Speaker says the frame once — 30 seconds each. Then switch.</a:t>
             </a:r>
             <a:endParaRPr lang="en-US" sz="1800" dirty="0"/>
           </a:p>
@@ -2628,7 +2628,7 @@
                 <a:ea typeface="Arial" pitchFamily="34" charset="-122"/>
                 <a:cs typeface="Arial" pitchFamily="34" charset="-120"/>
               </a:rPr>
-              <a:t>Listeners: tick eyes / voice / pace on the Speaker's sheet, then write one keep and one fix.</a:t>
+              <a:t>Listener 1 marks Speaker 1's sheet, Listener 2 marks Speaker 2's: eyes / voice / pace, keep, fix.</a:t>
             </a:r>
             <a:endParaRPr lang="en-US" sz="1800" dirty="0"/>
           </a:p>
@@ -3162,7 +3162,7 @@
                 <a:ea typeface="Arial" pitchFamily="34" charset="-122"/>
                 <a:cs typeface="Arial" pitchFamily="34" charset="-120"/>
               </a:rPr>
-              <a:t>Every AI job runs human → AI → human: a person starts it, AI does the middle, a person checks and decides. The people who win with AI are the ones who decide what it does.</a:t>
+              <a:t>Every AI job runs human → AI → human: a person starts it, AI does the middle, a person checks and decides. The people who win with AI tend to be the ones who decide what it does.</a:t>
             </a:r>
             <a:endParaRPr lang="en-US" sz="1600" dirty="0"/>
           </a:p>

</xml_diff>